<commit_message>
Slides update and course schedule upload.
</commit_message>
<xml_diff>
--- a/Day15/15-paev-andmetarkus-esitlus.pptx
+++ b/Day15/15-paev-andmetarkus-esitlus.pptx
@@ -14,9 +14,9 @@
     <p:sldId id="417" r:id="rId5"/>
     <p:sldId id="479" r:id="rId6"/>
     <p:sldId id="567" r:id="rId7"/>
-    <p:sldId id="475" r:id="rId8"/>
-    <p:sldId id="261" r:id="rId9"/>
-    <p:sldId id="452" r:id="rId10"/>
+    <p:sldId id="452" r:id="rId8"/>
+    <p:sldId id="475" r:id="rId9"/>
+    <p:sldId id="261" r:id="rId10"/>
     <p:sldId id="647" r:id="rId11"/>
     <p:sldId id="476" r:id="rId12"/>
     <p:sldId id="477" r:id="rId13"/>
@@ -165,7 +165,7 @@
 <file path=ppt/revisionInfo.xml><?xml version="1.0" encoding="utf-8"?>
 <p1510:revInfo xmlns:a="http://schemas.openxmlformats.org/drawingml/2006/main" xmlns:r="http://schemas.openxmlformats.org/officeDocument/2006/relationships" xmlns:p1510="http://schemas.microsoft.com/office/powerpoint/2015/10/main">
   <p1510:revLst>
-    <p1510:client id="{2EADCC2F-0731-4A5B-A287-B42682DA1D9C}" v="92" dt="2026-04-17T08:26:41.171"/>
+    <p1510:client id="{2EADCC2F-0731-4A5B-A287-B42682DA1D9C}" v="60" dt="2026-04-20T11:06:16.673"/>
   </p1510:revLst>
 </p1510:revInfo>
 </file>
@@ -174,65 +174,17 @@
 <pc:chgInfo xmlns:a="http://schemas.openxmlformats.org/drawingml/2006/main" xmlns:r="http://schemas.openxmlformats.org/officeDocument/2006/relationships" xmlns:ac="http://schemas.microsoft.com/office/drawing/2013/main/command" xmlns:pc="http://schemas.microsoft.com/office/powerpoint/2013/main/command">
   <pc:docChgLst>
     <pc:chgData name="Virve Räni" userId="161a7437-7ef4-49ec-91bf-54882f313dfe" providerId="ADAL" clId="{6D754EED-65AA-4A21-B175-6769012CF487}"/>
-    <pc:docChg chg="addSld delSld modSld sldOrd">
-      <pc:chgData name="Virve Räni" userId="161a7437-7ef4-49ec-91bf-54882f313dfe" providerId="ADAL" clId="{6D754EED-65AA-4A21-B175-6769012CF487}" dt="2026-04-17T08:27:10.969" v="544" actId="1076"/>
+    <pc:docChg chg="custSel addSld delSld modSld sldOrd">
+      <pc:chgData name="Virve Räni" userId="161a7437-7ef4-49ec-91bf-54882f313dfe" providerId="ADAL" clId="{6D754EED-65AA-4A21-B175-6769012CF487}" dt="2026-04-20T11:06:16.672" v="698" actId="20577"/>
       <pc:docMkLst>
         <pc:docMk/>
       </pc:docMkLst>
-      <pc:sldChg chg="modSp add mod">
-        <pc:chgData name="Virve Räni" userId="161a7437-7ef4-49ec-91bf-54882f313dfe" providerId="ADAL" clId="{6D754EED-65AA-4A21-B175-6769012CF487}" dt="2026-04-17T08:27:10.969" v="544" actId="1076"/>
+      <pc:sldChg chg="add">
+        <pc:chgData name="Virve Räni" userId="161a7437-7ef4-49ec-91bf-54882f313dfe" providerId="ADAL" clId="{6D754EED-65AA-4A21-B175-6769012CF487}" dt="2026-04-20T07:33:56.018" v="645"/>
         <pc:sldMkLst>
           <pc:docMk/>
           <pc:sldMk cId="0" sldId="261"/>
         </pc:sldMkLst>
-        <pc:spChg chg="mod">
-          <ac:chgData name="Virve Räni" userId="161a7437-7ef4-49ec-91bf-54882f313dfe" providerId="ADAL" clId="{6D754EED-65AA-4A21-B175-6769012CF487}" dt="2026-04-17T08:27:02.988" v="543" actId="20577"/>
-          <ac:spMkLst>
-            <pc:docMk/>
-            <pc:sldMk cId="0" sldId="261"/>
-            <ac:spMk id="2" creationId="{00000000-0000-0000-0000-000000000000}"/>
-          </ac:spMkLst>
-        </pc:spChg>
-        <pc:spChg chg="mod">
-          <ac:chgData name="Virve Räni" userId="161a7437-7ef4-49ec-91bf-54882f313dfe" providerId="ADAL" clId="{6D754EED-65AA-4A21-B175-6769012CF487}" dt="2026-04-17T08:27:10.969" v="544" actId="1076"/>
-          <ac:spMkLst>
-            <pc:docMk/>
-            <pc:sldMk cId="0" sldId="261"/>
-            <ac:spMk id="3" creationId="{00000000-0000-0000-0000-000000000000}"/>
-          </ac:spMkLst>
-        </pc:spChg>
-        <pc:spChg chg="mod">
-          <ac:chgData name="Virve Räni" userId="161a7437-7ef4-49ec-91bf-54882f313dfe" providerId="ADAL" clId="{6D754EED-65AA-4A21-B175-6769012CF487}" dt="2026-04-17T08:27:10.969" v="544" actId="1076"/>
-          <ac:spMkLst>
-            <pc:docMk/>
-            <pc:sldMk cId="0" sldId="261"/>
-            <ac:spMk id="4" creationId="{00000000-0000-0000-0000-000000000000}"/>
-          </ac:spMkLst>
-        </pc:spChg>
-        <pc:spChg chg="mod">
-          <ac:chgData name="Virve Räni" userId="161a7437-7ef4-49ec-91bf-54882f313dfe" providerId="ADAL" clId="{6D754EED-65AA-4A21-B175-6769012CF487}" dt="2026-04-17T08:27:10.969" v="544" actId="1076"/>
-          <ac:spMkLst>
-            <pc:docMk/>
-            <pc:sldMk cId="0" sldId="261"/>
-            <ac:spMk id="5" creationId="{00000000-0000-0000-0000-000000000000}"/>
-          </ac:spMkLst>
-        </pc:spChg>
-        <pc:spChg chg="mod">
-          <ac:chgData name="Virve Räni" userId="161a7437-7ef4-49ec-91bf-54882f313dfe" providerId="ADAL" clId="{6D754EED-65AA-4A21-B175-6769012CF487}" dt="2026-04-17T08:27:10.969" v="544" actId="1076"/>
-          <ac:spMkLst>
-            <pc:docMk/>
-            <pc:sldMk cId="0" sldId="261"/>
-            <ac:spMk id="6" creationId="{00000000-0000-0000-0000-000000000000}"/>
-          </ac:spMkLst>
-        </pc:spChg>
-        <pc:spChg chg="mod">
-          <ac:chgData name="Virve Räni" userId="161a7437-7ef4-49ec-91bf-54882f313dfe" providerId="ADAL" clId="{6D754EED-65AA-4A21-B175-6769012CF487}" dt="2026-04-17T08:27:10.969" v="544" actId="1076"/>
-          <ac:spMkLst>
-            <pc:docMk/>
-            <pc:sldMk cId="0" sldId="261"/>
-            <ac:spMk id="7" creationId="{00000000-0000-0000-0000-000000000000}"/>
-          </ac:spMkLst>
-        </pc:spChg>
       </pc:sldChg>
       <pc:sldChg chg="modSp mod">
         <pc:chgData name="Virve Räni" userId="161a7437-7ef4-49ec-91bf-54882f313dfe" providerId="ADAL" clId="{6D754EED-65AA-4A21-B175-6769012CF487}" dt="2026-04-14T08:06:07.883" v="377" actId="790"/>
@@ -303,8 +255,8 @@
           </ac:spMkLst>
         </pc:spChg>
       </pc:sldChg>
-      <pc:sldChg chg="modSp add mod">
-        <pc:chgData name="Virve Räni" userId="161a7437-7ef4-49ec-91bf-54882f313dfe" providerId="ADAL" clId="{6D754EED-65AA-4A21-B175-6769012CF487}" dt="2026-04-14T08:06:07.883" v="377" actId="790"/>
+      <pc:sldChg chg="modSp add mod ord">
+        <pc:chgData name="Virve Räni" userId="161a7437-7ef4-49ec-91bf-54882f313dfe" providerId="ADAL" clId="{6D754EED-65AA-4A21-B175-6769012CF487}" dt="2026-04-19T17:43:01.805" v="513"/>
         <pc:sldMkLst>
           <pc:docMk/>
           <pc:sldMk cId="3557357758" sldId="452"/>
@@ -449,8 +401,8 @@
           </ac:spMkLst>
         </pc:spChg>
       </pc:sldChg>
-      <pc:sldChg chg="modSp mod ord">
-        <pc:chgData name="Virve Räni" userId="161a7437-7ef4-49ec-91bf-54882f313dfe" providerId="ADAL" clId="{6D754EED-65AA-4A21-B175-6769012CF487}" dt="2026-04-14T08:06:47.771" v="379"/>
+      <pc:sldChg chg="modSp mod ord modAnim">
+        <pc:chgData name="Virve Räni" userId="161a7437-7ef4-49ec-91bf-54882f313dfe" providerId="ADAL" clId="{6D754EED-65AA-4A21-B175-6769012CF487}" dt="2026-04-20T11:06:16.672" v="698" actId="20577"/>
         <pc:sldMkLst>
           <pc:docMk/>
           <pc:sldMk cId="2641817430" sldId="514"/>
@@ -464,7 +416,7 @@
           </ac:spMkLst>
         </pc:spChg>
         <pc:spChg chg="mod">
-          <ac:chgData name="Virve Räni" userId="161a7437-7ef4-49ec-91bf-54882f313dfe" providerId="ADAL" clId="{6D754EED-65AA-4A21-B175-6769012CF487}" dt="2026-04-14T08:06:07.883" v="377" actId="790"/>
+          <ac:chgData name="Virve Räni" userId="161a7437-7ef4-49ec-91bf-54882f313dfe" providerId="ADAL" clId="{6D754EED-65AA-4A21-B175-6769012CF487}" dt="2026-04-20T11:06:16.672" v="698" actId="20577"/>
           <ac:spMkLst>
             <pc:docMk/>
             <pc:sldMk cId="2641817430" sldId="514"/>
@@ -564,8 +516,8 @@
           </ac:spMkLst>
         </pc:spChg>
       </pc:sldChg>
-      <pc:sldChg chg="modSp mod">
-        <pc:chgData name="Virve Räni" userId="161a7437-7ef4-49ec-91bf-54882f313dfe" providerId="ADAL" clId="{6D754EED-65AA-4A21-B175-6769012CF487}" dt="2026-04-14T08:06:07.883" v="377" actId="790"/>
+      <pc:sldChg chg="modSp mod modAnim">
+        <pc:chgData name="Virve Räni" userId="161a7437-7ef4-49ec-91bf-54882f313dfe" providerId="ADAL" clId="{6D754EED-65AA-4A21-B175-6769012CF487}" dt="2026-04-19T18:02:23.753" v="573"/>
         <pc:sldMkLst>
           <pc:docMk/>
           <pc:sldMk cId="3682630093" sldId="646"/>
@@ -579,7 +531,7 @@
           </ac:spMkLst>
         </pc:spChg>
         <pc:spChg chg="mod">
-          <ac:chgData name="Virve Räni" userId="161a7437-7ef4-49ec-91bf-54882f313dfe" providerId="ADAL" clId="{6D754EED-65AA-4A21-B175-6769012CF487}" dt="2026-04-14T08:06:07.883" v="377" actId="790"/>
+          <ac:chgData name="Virve Räni" userId="161a7437-7ef4-49ec-91bf-54882f313dfe" providerId="ADAL" clId="{6D754EED-65AA-4A21-B175-6769012CF487}" dt="2026-04-19T18:02:16.933" v="572" actId="20577"/>
           <ac:spMkLst>
             <pc:docMk/>
             <pc:sldMk cId="3682630093" sldId="646"/>
@@ -588,7 +540,7 @@
         </pc:spChg>
       </pc:sldChg>
       <pc:sldChg chg="modSp new mod">
-        <pc:chgData name="Virve Räni" userId="161a7437-7ef4-49ec-91bf-54882f313dfe" providerId="ADAL" clId="{6D754EED-65AA-4A21-B175-6769012CF487}" dt="2026-04-14T08:12:52.894" v="497" actId="20577"/>
+        <pc:chgData name="Virve Räni" userId="161a7437-7ef4-49ec-91bf-54882f313dfe" providerId="ADAL" clId="{6D754EED-65AA-4A21-B175-6769012CF487}" dt="2026-04-20T05:44:09.629" v="644" actId="20577"/>
         <pc:sldMkLst>
           <pc:docMk/>
           <pc:sldMk cId="1143583913" sldId="647"/>
@@ -602,7 +554,7 @@
           </ac:spMkLst>
         </pc:spChg>
         <pc:spChg chg="mod">
-          <ac:chgData name="Virve Räni" userId="161a7437-7ef4-49ec-91bf-54882f313dfe" providerId="ADAL" clId="{6D754EED-65AA-4A21-B175-6769012CF487}" dt="2026-04-14T08:12:52.894" v="497" actId="20577"/>
+          <ac:chgData name="Virve Räni" userId="161a7437-7ef4-49ec-91bf-54882f313dfe" providerId="ADAL" clId="{6D754EED-65AA-4A21-B175-6769012CF487}" dt="2026-04-20T05:44:09.629" v="644" actId="20577"/>
           <ac:spMkLst>
             <pc:docMk/>
             <pc:sldMk cId="1143583913" sldId="647"/>
@@ -709,7 +661,7 @@
           <a:p>
             <a:fld id="{F9D2AD6E-DEDD-49A0-A4BE-7A081A9112DA}" type="datetimeFigureOut">
               <a:rPr lang="en-US" smtClean="0"/>
-              <a:t>4/17/2026</a:t>
+              <a:t>4/20/2026</a:t>
             </a:fld>
             <a:endParaRPr lang="en-US"/>
           </a:p>
@@ -885,7 +837,7 @@
           </a:lstStyle>
           <a:p>
             <a:fld id="{2AF9C1A6-4321-41FA-B001-4140F0E2457F}" type="datetimeFigureOut">
-              <a:t>17.04.2026</a:t>
+              <a:t>20.04.2026</a:t>
             </a:fld>
             <a:endParaRPr lang="en-US"/>
           </a:p>
@@ -1302,7 +1254,7 @@
           <a:p>
             <a:fld id="{F7021451-1387-4CA6-816F-3879F97B5CBC}" type="slidenum">
               <a:rPr lang="en-US"/>
-              <a:t>5</a:t>
+              <a:t>6</a:t>
             </a:fld>
             <a:endParaRPr lang="en-US"/>
           </a:p>
@@ -12559,7 +12511,7 @@
           <a:p>
             <a:fld id="{DE840A40-73C8-4048-8140-49F5D65BB431}" type="datetimeFigureOut">
               <a:rPr lang="et-EE" smtClean="0"/>
-              <a:t>17.04.2026</a:t>
+              <a:t>20.04.2026</a:t>
             </a:fld>
             <a:endParaRPr lang="et-EE"/>
           </a:p>
@@ -13319,7 +13271,7 @@
     </p:spTree>
     <p:extLst>
       <p:ext uri="{BB962C8B-B14F-4D97-AF65-F5344CB8AC3E}">
-        <p14:creationId xmlns:p14="http://schemas.microsoft.com/office/powerpoint/2010/main" val="1857105681"/>
+        <p14:creationId xmlns:p14="http://schemas.microsoft.com/office/powerpoint/2010/main" val="18919152"/>
       </p:ext>
     </p:extLst>
   </p:cSld>
@@ -26389,10 +26341,10 @@
               <a:t>Nt </a:t>
             </a:r>
             <a:r>
-              <a:rPr lang="et-EE" sz="2400" noProof="0" dirty="0" err="1">
+              <a:rPr lang="en-US" sz="2400" noProof="0" dirty="0">
                 <a:ea typeface="Inter"/>
               </a:rPr>
-              <a:t>ChatGPT</a:t>
+              <a:t>Claude</a:t>
             </a:r>
             <a:r>
               <a:rPr lang="et-EE" sz="2400" noProof="0" dirty="0">
@@ -26401,24 +26353,80 @@
               <a:t> --&gt; kliki oma profiilil --&gt; </a:t>
             </a:r>
             <a:r>
-              <a:rPr lang="et-EE" sz="2400" noProof="0" dirty="0" err="1">
+              <a:rPr lang="en-US" sz="2400" dirty="0">
                 <a:ea typeface="Inter"/>
               </a:rPr>
-              <a:t>Customize</a:t>
+              <a:t>Settings</a:t>
+            </a:r>
+          </a:p>
+          <a:p>
+            <a:pPr lvl="1">
+              <a:lnSpc>
+                <a:spcPct val="150000"/>
+              </a:lnSpc>
+              <a:buFont typeface="Courier New" panose="020B0502030000000004" pitchFamily="34" charset="0"/>
+              <a:buChar char="o"/>
+            </a:pPr>
+            <a:endParaRPr lang="en-US" sz="2400" noProof="0" dirty="0">
+              <a:ea typeface="Inter"/>
+            </a:endParaRPr>
+          </a:p>
+          <a:p>
+            <a:pPr>
+              <a:lnSpc>
+                <a:spcPct val="150000"/>
+              </a:lnSpc>
+              <a:buFont typeface="Courier New" panose="020B0502030000000004" pitchFamily="34" charset="0"/>
+              <a:buChar char="o"/>
+            </a:pPr>
+            <a:r>
+              <a:rPr lang="en-US" sz="2400" dirty="0">
+                <a:ea typeface="Inter"/>
+              </a:rPr>
+              <a:t>Projects</a:t>
+            </a:r>
+          </a:p>
+          <a:p>
+            <a:pPr>
+              <a:lnSpc>
+                <a:spcPct val="150000"/>
+              </a:lnSpc>
+              <a:buFont typeface="Courier New" panose="020B0502030000000004" pitchFamily="34" charset="0"/>
+              <a:buChar char="o"/>
+            </a:pPr>
+            <a:endParaRPr lang="en-US" sz="2400" noProof="0" dirty="0">
+              <a:ea typeface="Inter"/>
+            </a:endParaRPr>
+          </a:p>
+          <a:p>
+            <a:pPr>
+              <a:lnSpc>
+                <a:spcPct val="150000"/>
+              </a:lnSpc>
+              <a:buFont typeface="Courier New" panose="020B0502030000000004" pitchFamily="34" charset="0"/>
+              <a:buChar char="o"/>
+            </a:pPr>
+            <a:r>
+              <a:rPr lang="en-US" sz="2400" dirty="0" err="1">
+                <a:ea typeface="Inter"/>
+              </a:rPr>
+              <a:t>Mudeli</a:t>
             </a:r>
             <a:r>
-              <a:rPr lang="et-EE" sz="2400" noProof="0" dirty="0">
+              <a:rPr lang="en-US" sz="2400" dirty="0">
                 <a:ea typeface="Inter"/>
               </a:rPr>
               <a:t> </a:t>
             </a:r>
             <a:r>
-              <a:rPr lang="et-EE" sz="2400" noProof="0" dirty="0" err="1">
+              <a:rPr lang="en-US" sz="2400" dirty="0" err="1">
                 <a:ea typeface="Inter"/>
               </a:rPr>
-              <a:t>ChatGPT</a:t>
+              <a:t>valik</a:t>
             </a:r>
-            <a:endParaRPr lang="et-EE" sz="2400" noProof="0" dirty="0"/>
+            <a:endParaRPr lang="en-US" sz="2400" noProof="0" dirty="0">
+              <a:ea typeface="Inter"/>
+            </a:endParaRPr>
           </a:p>
         </p:txBody>
       </p:sp>
@@ -26432,6 +26440,217 @@
   <p:clrMapOvr>
     <a:masterClrMapping/>
   </p:clrMapOvr>
+  <p:timing>
+    <p:tnLst>
+      <p:par>
+        <p:cTn id="1" dur="indefinite" restart="never" nodeType="tmRoot">
+          <p:childTnLst>
+            <p:seq concurrent="1" nextAc="seek">
+              <p:cTn id="2" dur="indefinite" nodeType="mainSeq">
+                <p:childTnLst>
+                  <p:par>
+                    <p:cTn id="3" fill="hold">
+                      <p:stCondLst>
+                        <p:cond delay="indefinite"/>
+                      </p:stCondLst>
+                      <p:childTnLst>
+                        <p:par>
+                          <p:cTn id="4" fill="hold">
+                            <p:stCondLst>
+                              <p:cond delay="0"/>
+                            </p:stCondLst>
+                            <p:childTnLst>
+                              <p:par>
+                                <p:cTn id="5" presetID="1" presetClass="entr" presetSubtype="0" fill="hold" grpId="0" nodeType="clickEffect">
+                                  <p:stCondLst>
+                                    <p:cond delay="0"/>
+                                  </p:stCondLst>
+                                  <p:childTnLst>
+                                    <p:set>
+                                      <p:cBhvr>
+                                        <p:cTn id="6" dur="1" fill="hold">
+                                          <p:stCondLst>
+                                            <p:cond delay="0"/>
+                                          </p:stCondLst>
+                                        </p:cTn>
+                                        <p:tgtEl>
+                                          <p:spTgt spid="3">
+                                            <p:txEl>
+                                              <p:pRg st="0" end="0"/>
+                                            </p:txEl>
+                                          </p:spTgt>
+                                        </p:tgtEl>
+                                        <p:attrNameLst>
+                                          <p:attrName>style.visibility</p:attrName>
+                                        </p:attrNameLst>
+                                      </p:cBhvr>
+                                      <p:to>
+                                        <p:strVal val="visible"/>
+                                      </p:to>
+                                    </p:set>
+                                  </p:childTnLst>
+                                </p:cTn>
+                              </p:par>
+                              <p:par>
+                                <p:cTn id="7" presetID="1" presetClass="entr" presetSubtype="0" fill="hold" grpId="0" nodeType="withEffect">
+                                  <p:stCondLst>
+                                    <p:cond delay="0"/>
+                                  </p:stCondLst>
+                                  <p:childTnLst>
+                                    <p:set>
+                                      <p:cBhvr>
+                                        <p:cTn id="8" dur="1" fill="hold">
+                                          <p:stCondLst>
+                                            <p:cond delay="0"/>
+                                          </p:stCondLst>
+                                        </p:cTn>
+                                        <p:tgtEl>
+                                          <p:spTgt spid="3">
+                                            <p:txEl>
+                                              <p:pRg st="1" end="1"/>
+                                            </p:txEl>
+                                          </p:spTgt>
+                                        </p:tgtEl>
+                                        <p:attrNameLst>
+                                          <p:attrName>style.visibility</p:attrName>
+                                        </p:attrNameLst>
+                                      </p:cBhvr>
+                                      <p:to>
+                                        <p:strVal val="visible"/>
+                                      </p:to>
+                                    </p:set>
+                                  </p:childTnLst>
+                                </p:cTn>
+                              </p:par>
+                            </p:childTnLst>
+                          </p:cTn>
+                        </p:par>
+                      </p:childTnLst>
+                    </p:cTn>
+                  </p:par>
+                  <p:par>
+                    <p:cTn id="9" fill="hold">
+                      <p:stCondLst>
+                        <p:cond delay="indefinite"/>
+                      </p:stCondLst>
+                      <p:childTnLst>
+                        <p:par>
+                          <p:cTn id="10" fill="hold">
+                            <p:stCondLst>
+                              <p:cond delay="0"/>
+                            </p:stCondLst>
+                            <p:childTnLst>
+                              <p:par>
+                                <p:cTn id="11" presetID="1" presetClass="entr" presetSubtype="0" fill="hold" grpId="0" nodeType="clickEffect">
+                                  <p:stCondLst>
+                                    <p:cond delay="0"/>
+                                  </p:stCondLst>
+                                  <p:childTnLst>
+                                    <p:set>
+                                      <p:cBhvr>
+                                        <p:cTn id="12" dur="1" fill="hold">
+                                          <p:stCondLst>
+                                            <p:cond delay="0"/>
+                                          </p:stCondLst>
+                                        </p:cTn>
+                                        <p:tgtEl>
+                                          <p:spTgt spid="3">
+                                            <p:txEl>
+                                              <p:pRg st="3" end="3"/>
+                                            </p:txEl>
+                                          </p:spTgt>
+                                        </p:tgtEl>
+                                        <p:attrNameLst>
+                                          <p:attrName>style.visibility</p:attrName>
+                                        </p:attrNameLst>
+                                      </p:cBhvr>
+                                      <p:to>
+                                        <p:strVal val="visible"/>
+                                      </p:to>
+                                    </p:set>
+                                  </p:childTnLst>
+                                </p:cTn>
+                              </p:par>
+                            </p:childTnLst>
+                          </p:cTn>
+                        </p:par>
+                      </p:childTnLst>
+                    </p:cTn>
+                  </p:par>
+                  <p:par>
+                    <p:cTn id="13" fill="hold">
+                      <p:stCondLst>
+                        <p:cond delay="indefinite"/>
+                      </p:stCondLst>
+                      <p:childTnLst>
+                        <p:par>
+                          <p:cTn id="14" fill="hold">
+                            <p:stCondLst>
+                              <p:cond delay="0"/>
+                            </p:stCondLst>
+                            <p:childTnLst>
+                              <p:par>
+                                <p:cTn id="15" presetID="1" presetClass="entr" presetSubtype="0" fill="hold" grpId="0" nodeType="clickEffect">
+                                  <p:stCondLst>
+                                    <p:cond delay="0"/>
+                                  </p:stCondLst>
+                                  <p:childTnLst>
+                                    <p:set>
+                                      <p:cBhvr>
+                                        <p:cTn id="16" dur="1" fill="hold">
+                                          <p:stCondLst>
+                                            <p:cond delay="0"/>
+                                          </p:stCondLst>
+                                        </p:cTn>
+                                        <p:tgtEl>
+                                          <p:spTgt spid="3">
+                                            <p:txEl>
+                                              <p:pRg st="5" end="5"/>
+                                            </p:txEl>
+                                          </p:spTgt>
+                                        </p:tgtEl>
+                                        <p:attrNameLst>
+                                          <p:attrName>style.visibility</p:attrName>
+                                        </p:attrNameLst>
+                                      </p:cBhvr>
+                                      <p:to>
+                                        <p:strVal val="visible"/>
+                                      </p:to>
+                                    </p:set>
+                                  </p:childTnLst>
+                                </p:cTn>
+                              </p:par>
+                            </p:childTnLst>
+                          </p:cTn>
+                        </p:par>
+                      </p:childTnLst>
+                    </p:cTn>
+                  </p:par>
+                </p:childTnLst>
+              </p:cTn>
+              <p:prevCondLst>
+                <p:cond evt="onPrev" delay="0">
+                  <p:tgtEl>
+                    <p:sldTgt/>
+                  </p:tgtEl>
+                </p:cond>
+              </p:prevCondLst>
+              <p:nextCondLst>
+                <p:cond evt="onNext" delay="0">
+                  <p:tgtEl>
+                    <p:sldTgt/>
+                  </p:tgtEl>
+                </p:cond>
+              </p:nextCondLst>
+            </p:seq>
+          </p:childTnLst>
+        </p:cTn>
+      </p:par>
+    </p:tnLst>
+    <p:bldLst>
+      <p:bldP spid="3" grpId="0" build="p"/>
+    </p:bldLst>
+  </p:timing>
 </p:sld>
 </file>
 
@@ -26640,6 +26859,75 @@
               <a:t>Ava  Müügiraporti Power BI </a:t>
             </a:r>
             <a:endParaRPr lang="et-EE" sz="2400" noProof="0" dirty="0">
+              <a:cs typeface="Noto Serif"/>
+            </a:endParaRPr>
+          </a:p>
+          <a:p>
+            <a:pPr marL="857250" lvl="1" indent="-342900">
+              <a:lnSpc>
+                <a:spcPct val="150000"/>
+              </a:lnSpc>
+              <a:buFont typeface="Arial,Sans-Serif" panose="020B0502030000000004" pitchFamily="34" charset="0"/>
+              <a:buChar char="o"/>
+            </a:pPr>
+            <a:r>
+              <a:rPr lang="en-US" sz="2400" noProof="0" dirty="0">
+                <a:ea typeface="Inter"/>
+                <a:cs typeface="Noto Serif"/>
+              </a:rPr>
+              <a:t>Palu </a:t>
+            </a:r>
+            <a:r>
+              <a:rPr lang="en-US" sz="2400" noProof="0" dirty="0" err="1">
+                <a:ea typeface="Inter"/>
+                <a:cs typeface="Noto Serif"/>
+              </a:rPr>
+              <a:t>vestlusrobotitel</a:t>
+            </a:r>
+            <a:r>
+              <a:rPr lang="en-US" sz="2400" noProof="0" dirty="0">
+                <a:ea typeface="Inter"/>
+                <a:cs typeface="Noto Serif"/>
+              </a:rPr>
+              <a:t> </a:t>
+            </a:r>
+            <a:r>
+              <a:rPr lang="en-US" sz="2400" noProof="0" dirty="0" err="1">
+                <a:ea typeface="Inter"/>
+                <a:cs typeface="Noto Serif"/>
+              </a:rPr>
+              <a:t>selgitada</a:t>
+            </a:r>
+            <a:r>
+              <a:rPr lang="en-US" sz="2400" noProof="0" dirty="0">
+                <a:ea typeface="Inter"/>
+                <a:cs typeface="Noto Serif"/>
+              </a:rPr>
+              <a:t> </a:t>
+            </a:r>
+            <a:r>
+              <a:rPr lang="en-US" sz="2400" noProof="0" dirty="0" err="1">
+                <a:ea typeface="Inter"/>
+                <a:cs typeface="Noto Serif"/>
+              </a:rPr>
+              <a:t>saadud</a:t>
+            </a:r>
+            <a:r>
+              <a:rPr lang="en-US" sz="2400" noProof="0" dirty="0">
+                <a:ea typeface="Inter"/>
+                <a:cs typeface="Noto Serif"/>
+              </a:rPr>
+              <a:t> </a:t>
+            </a:r>
+            <a:r>
+              <a:rPr lang="en-US" sz="2400" noProof="0" dirty="0" err="1">
+                <a:ea typeface="Inter"/>
+                <a:cs typeface="Noto Serif"/>
+              </a:rPr>
+              <a:t>mõõdikuid</a:t>
+            </a:r>
+            <a:endParaRPr lang="en-US" sz="2400" noProof="0" dirty="0">
+              <a:ea typeface="Inter"/>
               <a:cs typeface="Noto Serif"/>
             </a:endParaRPr>
           </a:p>
@@ -26878,33 +27166,15 @@
                                   </p:childTnLst>
                                 </p:cTn>
                               </p:par>
-                            </p:childTnLst>
-                          </p:cTn>
-                        </p:par>
-                      </p:childTnLst>
-                    </p:cTn>
-                  </p:par>
-                  <p:par>
-                    <p:cTn id="9" fill="hold">
-                      <p:stCondLst>
-                        <p:cond delay="indefinite"/>
-                      </p:stCondLst>
-                      <p:childTnLst>
-                        <p:par>
-                          <p:cTn id="10" fill="hold">
-                            <p:stCondLst>
-                              <p:cond delay="0"/>
-                            </p:stCondLst>
-                            <p:childTnLst>
                               <p:par>
-                                <p:cTn id="11" presetID="1" presetClass="entr" presetSubtype="0" fill="hold" grpId="0" nodeType="clickEffect">
+                                <p:cTn id="9" presetID="1" presetClass="entr" presetSubtype="0" fill="hold" grpId="0" nodeType="withEffect">
                                   <p:stCondLst>
                                     <p:cond delay="0"/>
                                   </p:stCondLst>
                                   <p:childTnLst>
                                     <p:set>
                                       <p:cBhvr>
-                                        <p:cTn id="12" dur="1" fill="hold">
+                                        <p:cTn id="10" dur="1" fill="hold">
                                           <p:stCondLst>
                                             <p:cond delay="0"/>
                                           </p:stCondLst>
@@ -26913,6 +27183,55 @@
                                           <p:spTgt spid="3">
                                             <p:txEl>
                                               <p:pRg st="2" end="2"/>
+                                            </p:txEl>
+                                          </p:spTgt>
+                                        </p:tgtEl>
+                                        <p:attrNameLst>
+                                          <p:attrName>style.visibility</p:attrName>
+                                        </p:attrNameLst>
+                                      </p:cBhvr>
+                                      <p:to>
+                                        <p:strVal val="visible"/>
+                                      </p:to>
+                                    </p:set>
+                                  </p:childTnLst>
+                                </p:cTn>
+                              </p:par>
+                            </p:childTnLst>
+                          </p:cTn>
+                        </p:par>
+                      </p:childTnLst>
+                    </p:cTn>
+                  </p:par>
+                  <p:par>
+                    <p:cTn id="11" fill="hold">
+                      <p:stCondLst>
+                        <p:cond delay="indefinite"/>
+                      </p:stCondLst>
+                      <p:childTnLst>
+                        <p:par>
+                          <p:cTn id="12" fill="hold">
+                            <p:stCondLst>
+                              <p:cond delay="0"/>
+                            </p:stCondLst>
+                            <p:childTnLst>
+                              <p:par>
+                                <p:cTn id="13" presetID="1" presetClass="entr" presetSubtype="0" fill="hold" grpId="0" nodeType="clickEffect">
+                                  <p:stCondLst>
+                                    <p:cond delay="0"/>
+                                  </p:stCondLst>
+                                  <p:childTnLst>
+                                    <p:set>
+                                      <p:cBhvr>
+                                        <p:cTn id="14" dur="1" fill="hold">
+                                          <p:stCondLst>
+                                            <p:cond delay="0"/>
+                                          </p:stCondLst>
+                                        </p:cTn>
+                                        <p:tgtEl>
+                                          <p:spTgt spid="3">
+                                            <p:txEl>
+                                              <p:pRg st="3" end="3"/>
                                             </p:txEl>
                                           </p:spTgt>
                                         </p:tgtEl>
@@ -28317,6 +28636,458 @@
   <p:cSld>
     <p:spTree>
       <p:nvGrpSpPr>
+        <p:cNvPr id="1" name=""/>
+        <p:cNvGrpSpPr/>
+        <p:nvPr/>
+      </p:nvGrpSpPr>
+      <p:grpSpPr>
+        <a:xfrm>
+          <a:off x="0" y="0"/>
+          <a:ext cx="0" cy="0"/>
+          <a:chOff x="0" y="0"/>
+          <a:chExt cx="0" cy="0"/>
+        </a:xfrm>
+      </p:grpSpPr>
+      <p:sp>
+        <p:nvSpPr>
+          <p:cNvPr id="2" name="Title 1">
+            <a:extLst>
+              <a:ext uri="{FF2B5EF4-FFF2-40B4-BE49-F238E27FC236}">
+                <a16:creationId xmlns:a16="http://schemas.microsoft.com/office/drawing/2014/main" id="{8181DBF1-6B0C-F0AB-B6AE-072A389A2741}"/>
+              </a:ext>
+            </a:extLst>
+          </p:cNvPr>
+          <p:cNvSpPr>
+            <a:spLocks noGrp="1"/>
+          </p:cNvSpPr>
+          <p:nvPr>
+            <p:ph type="ctrTitle"/>
+          </p:nvPr>
+        </p:nvSpPr>
+        <p:spPr/>
+        <p:txBody>
+          <a:bodyPr/>
+          <a:lstStyle/>
+          <a:p>
+            <a:r>
+              <a:rPr lang="et-EE" noProof="0" dirty="0"/>
+              <a:t>Kuidas generatiivne tehisaru töötab?</a:t>
+            </a:r>
+          </a:p>
+        </p:txBody>
+      </p:sp>
+      <p:sp>
+        <p:nvSpPr>
+          <p:cNvPr id="9" name="TextBox 8">
+            <a:extLst>
+              <a:ext uri="{FF2B5EF4-FFF2-40B4-BE49-F238E27FC236}">
+                <a16:creationId xmlns:a16="http://schemas.microsoft.com/office/drawing/2014/main" id="{2C7597CA-D61E-17DA-17B5-C9C1738A73BE}"/>
+              </a:ext>
+            </a:extLst>
+          </p:cNvPr>
+          <p:cNvSpPr txBox="1"/>
+          <p:nvPr/>
+        </p:nvSpPr>
+        <p:spPr>
+          <a:xfrm>
+            <a:off x="650240" y="1188720"/>
+            <a:ext cx="5161280" cy="646331"/>
+          </a:xfrm>
+          <a:prstGeom prst="rect">
+            <a:avLst/>
+          </a:prstGeom>
+          <a:noFill/>
+        </p:spPr>
+        <p:txBody>
+          <a:bodyPr rot="0" spcFirstLastPara="0" vertOverflow="overflow" horzOverflow="overflow" vert="horz" wrap="square" lIns="91440" tIns="45720" rIns="91440" bIns="45720" numCol="1" spcCol="0" rtlCol="0" fromWordArt="0" anchor="t" anchorCtr="0" forceAA="0" compatLnSpc="1">
+            <a:prstTxWarp prst="textNoShape">
+              <a:avLst/>
+            </a:prstTxWarp>
+            <a:spAutoFit/>
+          </a:bodyPr>
+          <a:lstStyle/>
+          <a:p>
+            <a:pPr marL="285750" indent="-285750">
+              <a:buFont typeface="Arial"/>
+              <a:buChar char="•"/>
+            </a:pPr>
+            <a:r>
+              <a:rPr lang="et-EE" noProof="0" dirty="0">
+                <a:ea typeface="Inter"/>
+              </a:rPr>
+              <a:t>Mida arvasid ameeriklased augustis 2025:</a:t>
+            </a:r>
+            <a:endParaRPr lang="et-EE" noProof="0" dirty="0"/>
+          </a:p>
+          <a:p>
+            <a:pPr marL="285750" indent="-285750">
+              <a:buFont typeface="Arial"/>
+              <a:buChar char="•"/>
+            </a:pPr>
+            <a:endParaRPr lang="et-EE" noProof="0" dirty="0"/>
+          </a:p>
+        </p:txBody>
+      </p:sp>
+      <p:pic>
+        <p:nvPicPr>
+          <p:cNvPr id="12" name="Content Placeholder 11">
+            <a:extLst>
+              <a:ext uri="{FF2B5EF4-FFF2-40B4-BE49-F238E27FC236}">
+                <a16:creationId xmlns:a16="http://schemas.microsoft.com/office/drawing/2014/main" id="{DDF6099E-FFF5-3B8B-6ED0-48C668AABFB9}"/>
+              </a:ext>
+            </a:extLst>
+          </p:cNvPr>
+          <p:cNvPicPr>
+            <a:picLocks noGrp="1" noChangeAspect="1"/>
+          </p:cNvPicPr>
+          <p:nvPr>
+            <p:ph sz="quarter" idx="10"/>
+          </p:nvPr>
+        </p:nvPicPr>
+        <p:blipFill>
+          <a:blip r:embed="rId2"/>
+          <a:stretch>
+            <a:fillRect/>
+          </a:stretch>
+        </p:blipFill>
+        <p:spPr>
+          <a:xfrm>
+            <a:off x="2055813" y="1836261"/>
+            <a:ext cx="8077200" cy="4000500"/>
+          </a:xfrm>
+          <a:prstGeom prst="rect">
+            <a:avLst/>
+          </a:prstGeom>
+          <a:solidFill>
+            <a:srgbClr val="FFFFFF">
+              <a:shade val="85000"/>
+            </a:srgbClr>
+          </a:solidFill>
+          <a:ln w="88900" cap="sq">
+            <a:solidFill>
+              <a:srgbClr val="FFFFFF"/>
+            </a:solidFill>
+            <a:miter lim="800000"/>
+          </a:ln>
+          <a:effectLst>
+            <a:outerShdw blurRad="55000" dist="18000" dir="5400000" algn="tl" rotWithShape="0">
+              <a:srgbClr val="000000">
+                <a:alpha val="40000"/>
+              </a:srgbClr>
+            </a:outerShdw>
+          </a:effectLst>
+          <a:scene3d>
+            <a:camera prst="orthographicFront"/>
+            <a:lightRig rig="twoPt" dir="t">
+              <a:rot lat="0" lon="0" rev="7200000"/>
+            </a:lightRig>
+          </a:scene3d>
+          <a:sp3d>
+            <a:bevelT w="25400" h="19050"/>
+            <a:contourClr>
+              <a:srgbClr val="FFFFFF"/>
+            </a:contourClr>
+          </a:sp3d>
+        </p:spPr>
+      </p:pic>
+      <p:sp>
+        <p:nvSpPr>
+          <p:cNvPr id="13" name="TextBox 12">
+            <a:extLst>
+              <a:ext uri="{FF2B5EF4-FFF2-40B4-BE49-F238E27FC236}">
+                <a16:creationId xmlns:a16="http://schemas.microsoft.com/office/drawing/2014/main" id="{7D4B374B-E0FB-F26A-AAD2-2AA0ED2D1C5C}"/>
+              </a:ext>
+            </a:extLst>
+          </p:cNvPr>
+          <p:cNvSpPr txBox="1"/>
+          <p:nvPr/>
+        </p:nvSpPr>
+        <p:spPr>
+          <a:xfrm>
+            <a:off x="2692400" y="6014720"/>
+            <a:ext cx="7518400" cy="923330"/>
+          </a:xfrm>
+          <a:prstGeom prst="rect">
+            <a:avLst/>
+          </a:prstGeom>
+          <a:noFill/>
+        </p:spPr>
+        <p:txBody>
+          <a:bodyPr rot="0" spcFirstLastPara="0" vertOverflow="overflow" horzOverflow="overflow" vert="horz" wrap="square" lIns="91440" tIns="45720" rIns="91440" bIns="45720" numCol="1" spcCol="0" rtlCol="0" fromWordArt="0" anchor="t" anchorCtr="0" forceAA="0" compatLnSpc="1">
+            <a:prstTxWarp prst="textNoShape">
+              <a:avLst/>
+            </a:prstTxWarp>
+            <a:spAutoFit/>
+          </a:bodyPr>
+          <a:lstStyle/>
+          <a:p>
+            <a:pPr algn="r"/>
+            <a:r>
+              <a:rPr lang="et-EE" sz="1400" noProof="0" dirty="0">
+                <a:ea typeface="Inter"/>
+              </a:rPr>
+              <a:t>Allikas:</a:t>
+            </a:r>
+            <a:r>
+              <a:rPr lang="et-EE" sz="1400" noProof="0" dirty="0">
+                <a:ea typeface="+mn-lt"/>
+                <a:cs typeface="+mn-lt"/>
+              </a:rPr>
+              <a:t> </a:t>
+            </a:r>
+            <a:r>
+              <a:rPr lang="et-EE" sz="1400" noProof="0" dirty="0" err="1">
+                <a:ea typeface="+mn-lt"/>
+                <a:cs typeface="+mn-lt"/>
+                <a:hlinkClick r:id="rId3"/>
+              </a:rPr>
+              <a:t>Searchlight</a:t>
+            </a:r>
+            <a:r>
+              <a:rPr lang="et-EE" sz="1400" noProof="0" dirty="0">
+                <a:ea typeface="+mn-lt"/>
+                <a:cs typeface="+mn-lt"/>
+                <a:hlinkClick r:id="rId3"/>
+              </a:rPr>
+              <a:t> </a:t>
+            </a:r>
+            <a:r>
+              <a:rPr lang="et-EE" sz="1400" noProof="0" dirty="0" err="1">
+                <a:ea typeface="+mn-lt"/>
+                <a:cs typeface="+mn-lt"/>
+                <a:hlinkClick r:id="rId3"/>
+              </a:rPr>
+              <a:t>Institute</a:t>
+            </a:r>
+            <a:r>
+              <a:rPr lang="et-EE" sz="1400" noProof="0" dirty="0">
+                <a:ea typeface="+mn-lt"/>
+                <a:cs typeface="+mn-lt"/>
+                <a:hlinkClick r:id="rId3"/>
+              </a:rPr>
+              <a:t> ja Tavern Research uuring AI kohta</a:t>
+            </a:r>
+            <a:r>
+              <a:rPr lang="et-EE" sz="1400" noProof="0" dirty="0">
+                <a:ea typeface="+mn-lt"/>
+                <a:cs typeface="+mn-lt"/>
+              </a:rPr>
+              <a:t>.</a:t>
+            </a:r>
+            <a:r>
+              <a:rPr lang="et-EE" noProof="0" dirty="0">
+                <a:ea typeface="+mn-lt"/>
+                <a:cs typeface="+mn-lt"/>
+              </a:rPr>
+              <a:t> </a:t>
+            </a:r>
+            <a:endParaRPr lang="et-EE" noProof="0" dirty="0">
+              <a:ea typeface="Inter"/>
+            </a:endParaRPr>
+          </a:p>
+          <a:p>
+            <a:pPr algn="r"/>
+            <a:endParaRPr lang="et-EE" noProof="0" dirty="0">
+              <a:solidFill>
+                <a:srgbClr val="121212"/>
+              </a:solidFill>
+              <a:ea typeface="Inter"/>
+            </a:endParaRPr>
+          </a:p>
+          <a:p>
+            <a:endParaRPr lang="et-EE" noProof="0" dirty="0">
+              <a:ea typeface="Inter"/>
+            </a:endParaRPr>
+          </a:p>
+        </p:txBody>
+      </p:sp>
+    </p:spTree>
+    <p:extLst>
+      <p:ext uri="{BB962C8B-B14F-4D97-AF65-F5344CB8AC3E}">
+        <p14:creationId xmlns:p14="http://schemas.microsoft.com/office/powerpoint/2010/main" val="3557357758"/>
+      </p:ext>
+    </p:extLst>
+  </p:cSld>
+  <p:clrMapOvr>
+    <a:masterClrMapping/>
+  </p:clrMapOvr>
+  <p:timing>
+    <p:tnLst>
+      <p:par>
+        <p:cTn id="1" dur="indefinite" restart="never" nodeType="tmRoot">
+          <p:childTnLst>
+            <p:seq concurrent="1" nextAc="seek">
+              <p:cTn id="2" dur="indefinite" nodeType="mainSeq">
+                <p:childTnLst>
+                  <p:par>
+                    <p:cTn id="3" fill="hold">
+                      <p:stCondLst>
+                        <p:cond delay="indefinite"/>
+                      </p:stCondLst>
+                      <p:childTnLst>
+                        <p:par>
+                          <p:cTn id="4" fill="hold">
+                            <p:stCondLst>
+                              <p:cond delay="0"/>
+                            </p:stCondLst>
+                            <p:childTnLst>
+                              <p:par>
+                                <p:cTn id="5" presetID="1" presetClass="entr" presetSubtype="0" fill="hold" grpId="0" nodeType="clickEffect">
+                                  <p:stCondLst>
+                                    <p:cond delay="0"/>
+                                  </p:stCondLst>
+                                  <p:childTnLst>
+                                    <p:set>
+                                      <p:cBhvr>
+                                        <p:cTn id="6" dur="1" fill="hold">
+                                          <p:stCondLst>
+                                            <p:cond delay="0"/>
+                                          </p:stCondLst>
+                                        </p:cTn>
+                                        <p:tgtEl>
+                                          <p:spTgt spid="9"/>
+                                        </p:tgtEl>
+                                        <p:attrNameLst>
+                                          <p:attrName>style.visibility</p:attrName>
+                                        </p:attrNameLst>
+                                      </p:cBhvr>
+                                      <p:to>
+                                        <p:strVal val="visible"/>
+                                      </p:to>
+                                    </p:set>
+                                  </p:childTnLst>
+                                </p:cTn>
+                              </p:par>
+                            </p:childTnLst>
+                          </p:cTn>
+                        </p:par>
+                      </p:childTnLst>
+                    </p:cTn>
+                  </p:par>
+                  <p:par>
+                    <p:cTn id="7" fill="hold">
+                      <p:stCondLst>
+                        <p:cond delay="indefinite"/>
+                      </p:stCondLst>
+                      <p:childTnLst>
+                        <p:par>
+                          <p:cTn id="8" fill="hold">
+                            <p:stCondLst>
+                              <p:cond delay="0"/>
+                            </p:stCondLst>
+                            <p:childTnLst>
+                              <p:par>
+                                <p:cTn id="9" presetID="1" presetClass="entr" presetSubtype="0" fill="hold" nodeType="clickEffect">
+                                  <p:stCondLst>
+                                    <p:cond delay="0"/>
+                                  </p:stCondLst>
+                                  <p:childTnLst>
+                                    <p:set>
+                                      <p:cBhvr>
+                                        <p:cTn id="10" dur="1" fill="hold">
+                                          <p:stCondLst>
+                                            <p:cond delay="0"/>
+                                          </p:stCondLst>
+                                        </p:cTn>
+                                        <p:tgtEl>
+                                          <p:spTgt spid="12"/>
+                                        </p:tgtEl>
+                                        <p:attrNameLst>
+                                          <p:attrName>style.visibility</p:attrName>
+                                        </p:attrNameLst>
+                                      </p:cBhvr>
+                                      <p:to>
+                                        <p:strVal val="visible"/>
+                                      </p:to>
+                                    </p:set>
+                                  </p:childTnLst>
+                                </p:cTn>
+                              </p:par>
+                            </p:childTnLst>
+                          </p:cTn>
+                        </p:par>
+                      </p:childTnLst>
+                    </p:cTn>
+                  </p:par>
+                  <p:par>
+                    <p:cTn id="11" fill="hold">
+                      <p:stCondLst>
+                        <p:cond delay="indefinite"/>
+                      </p:stCondLst>
+                      <p:childTnLst>
+                        <p:par>
+                          <p:cTn id="12" fill="hold">
+                            <p:stCondLst>
+                              <p:cond delay="0"/>
+                            </p:stCondLst>
+                            <p:childTnLst>
+                              <p:par>
+                                <p:cTn id="13" presetID="1" presetClass="entr" presetSubtype="0" fill="hold" grpId="0" nodeType="clickEffect">
+                                  <p:stCondLst>
+                                    <p:cond delay="0"/>
+                                  </p:stCondLst>
+                                  <p:childTnLst>
+                                    <p:set>
+                                      <p:cBhvr>
+                                        <p:cTn id="14" dur="1" fill="hold">
+                                          <p:stCondLst>
+                                            <p:cond delay="0"/>
+                                          </p:stCondLst>
+                                        </p:cTn>
+                                        <p:tgtEl>
+                                          <p:spTgt spid="13"/>
+                                        </p:tgtEl>
+                                        <p:attrNameLst>
+                                          <p:attrName>style.visibility</p:attrName>
+                                        </p:attrNameLst>
+                                      </p:cBhvr>
+                                      <p:to>
+                                        <p:strVal val="visible"/>
+                                      </p:to>
+                                    </p:set>
+                                  </p:childTnLst>
+                                </p:cTn>
+                              </p:par>
+                            </p:childTnLst>
+                          </p:cTn>
+                        </p:par>
+                      </p:childTnLst>
+                    </p:cTn>
+                  </p:par>
+                </p:childTnLst>
+              </p:cTn>
+              <p:prevCondLst>
+                <p:cond evt="onPrev" delay="0">
+                  <p:tgtEl>
+                    <p:sldTgt/>
+                  </p:tgtEl>
+                </p:cond>
+              </p:prevCondLst>
+              <p:nextCondLst>
+                <p:cond evt="onNext" delay="0">
+                  <p:tgtEl>
+                    <p:sldTgt/>
+                  </p:tgtEl>
+                </p:cond>
+              </p:nextCondLst>
+            </p:seq>
+          </p:childTnLst>
+        </p:cTn>
+      </p:par>
+    </p:tnLst>
+    <p:bldLst>
+      <p:bldP spid="9" grpId="0"/>
+      <p:bldP spid="13" grpId="0"/>
+    </p:bldLst>
+  </p:timing>
+</p:sld>
+</file>
+
+<file path=ppt/slides/slide5.xml><?xml version="1.0" encoding="utf-8"?>
+<p:sld xmlns:a="http://schemas.openxmlformats.org/drawingml/2006/main" xmlns:r="http://schemas.openxmlformats.org/officeDocument/2006/relationships" xmlns:p="http://schemas.openxmlformats.org/presentationml/2006/main">
+  <p:cSld>
+    <p:spTree>
+      <p:nvGrpSpPr>
         <p:cNvPr id="1" name="">
           <a:extLst>
             <a:ext uri="{FF2B5EF4-FFF2-40B4-BE49-F238E27FC236}">
@@ -29165,7 +29936,7 @@
 </p:sld>
 </file>
 
-<file path=ppt/slides/slide5.xml><?xml version="1.0" encoding="utf-8"?>
+<file path=ppt/slides/slide6.xml><?xml version="1.0" encoding="utf-8"?>
 <p:sld xmlns:a="http://schemas.openxmlformats.org/drawingml/2006/main" xmlns:r="http://schemas.openxmlformats.org/officeDocument/2006/relationships" xmlns:p="http://schemas.openxmlformats.org/presentationml/2006/main">
   <p:cSld>
     <p:spTree>
@@ -29190,7 +29961,7 @@
         </p:nvSpPr>
         <p:spPr>
           <a:xfrm>
-            <a:off x="579196" y="956041"/>
+            <a:off x="661492" y="1888729"/>
             <a:ext cx="9836051" cy="590649"/>
           </a:xfrm>
           <a:prstGeom prst="rect">
@@ -29209,16 +29980,6 @@
               </a:lnSpc>
             </a:pPr>
             <a:r>
-              <a:rPr lang="en-US" sz="3708" b="1" dirty="0" err="1">
-                <a:solidFill>
-                  <a:srgbClr val="000000"/>
-                </a:solidFill>
-                <a:ea typeface="Inter Bold" pitchFamily="34" charset="-122"/>
-                <a:cs typeface="Inter Bold" pitchFamily="34" charset="-120"/>
-              </a:rPr>
-              <a:t>Generatiivne</a:t>
-            </a:r>
-            <a:r>
               <a:rPr lang="en-US" sz="3708" b="1" dirty="0">
                 <a:solidFill>
                   <a:srgbClr val="000000"/>
@@ -29226,27 +29987,7 @@
                 <a:ea typeface="Inter Bold" pitchFamily="34" charset="-122"/>
                 <a:cs typeface="Inter Bold" pitchFamily="34" charset="-120"/>
               </a:rPr>
-              <a:t> </a:t>
-            </a:r>
-            <a:r>
-              <a:rPr lang="en-US" sz="3708" b="1" dirty="0" err="1">
-                <a:solidFill>
-                  <a:srgbClr val="000000"/>
-                </a:solidFill>
-                <a:ea typeface="Inter Bold" pitchFamily="34" charset="-122"/>
-                <a:cs typeface="Inter Bold" pitchFamily="34" charset="-120"/>
-              </a:rPr>
-              <a:t>tehisaru</a:t>
-            </a:r>
-            <a:r>
-              <a:rPr lang="en-US" sz="3708" b="1" dirty="0">
-                <a:solidFill>
-                  <a:srgbClr val="000000"/>
-                </a:solidFill>
-                <a:ea typeface="Inter Bold" pitchFamily="34" charset="-122"/>
-                <a:cs typeface="Inter Bold" pitchFamily="34" charset="-120"/>
-              </a:rPr>
-              <a:t> vs traditsiooniline tarkvara</a:t>
+              <a:t>Generatiivne AI vs traditsiooniline tarkvara</a:t>
             </a:r>
             <a:endParaRPr lang="en-US" sz="3708" dirty="0"/>
           </a:p>
@@ -29260,7 +30001,7 @@
         </p:nvSpPr>
         <p:spPr>
           <a:xfrm>
-            <a:off x="560685" y="2348353"/>
+            <a:off x="661492" y="2951857"/>
             <a:ext cx="3642916" cy="354409"/>
           </a:xfrm>
           <a:prstGeom prst="rect">
@@ -29300,7 +30041,7 @@
         </p:nvSpPr>
         <p:spPr>
           <a:xfrm>
-            <a:off x="560685" y="2891775"/>
+            <a:off x="661492" y="3495279"/>
             <a:ext cx="5203924" cy="1407914"/>
           </a:xfrm>
           <a:prstGeom prst="rect">
@@ -29402,7 +30143,7 @@
         </p:nvSpPr>
         <p:spPr>
           <a:xfrm>
-            <a:off x="6096000" y="2159341"/>
+            <a:off x="6196807" y="2762845"/>
             <a:ext cx="5476181" cy="2206427"/>
           </a:xfrm>
           <a:prstGeom prst="roundRect">
@@ -29431,7 +30172,7 @@
         </p:nvSpPr>
         <p:spPr>
           <a:xfrm>
-            <a:off x="6285012" y="2348353"/>
+            <a:off x="6385819" y="2951857"/>
             <a:ext cx="3655219" cy="354409"/>
           </a:xfrm>
           <a:prstGeom prst="rect">
@@ -29450,16 +30191,6 @@
               </a:lnSpc>
             </a:pPr>
             <a:r>
-              <a:rPr lang="en-US" sz="2208" b="1" dirty="0" err="1">
-                <a:solidFill>
-                  <a:srgbClr val="FFFFFF"/>
-                </a:solidFill>
-                <a:ea typeface="Inter Bold" pitchFamily="34" charset="-122"/>
-                <a:cs typeface="Inter Bold" pitchFamily="34" charset="-120"/>
-              </a:rPr>
-              <a:t>Generatiivne</a:t>
-            </a:r>
-            <a:r>
               <a:rPr lang="en-US" sz="2208" b="1" dirty="0">
                 <a:solidFill>
                   <a:srgbClr val="FFFFFF"/>
@@ -29467,17 +30198,7 @@
                 <a:ea typeface="Inter Bold" pitchFamily="34" charset="-122"/>
                 <a:cs typeface="Inter Bold" pitchFamily="34" charset="-120"/>
               </a:rPr>
-              <a:t> </a:t>
-            </a:r>
-            <a:r>
-              <a:rPr lang="en-US" sz="2208" b="1" dirty="0" err="1">
-                <a:solidFill>
-                  <a:srgbClr val="FFFFFF"/>
-                </a:solidFill>
-                <a:ea typeface="Inter Bold" pitchFamily="34" charset="-122"/>
-                <a:cs typeface="Inter Bold" pitchFamily="34" charset="-120"/>
-              </a:rPr>
-              <a:t>tehisaru</a:t>
+              <a:t>Generatiivne AI (ChatGPT)</a:t>
             </a:r>
             <a:endParaRPr lang="en-US" sz="2208" dirty="0"/>
           </a:p>
@@ -29491,7 +30212,7 @@
         </p:nvSpPr>
         <p:spPr>
           <a:xfrm>
-            <a:off x="6285011" y="2891775"/>
+            <a:off x="6385818" y="3495279"/>
             <a:ext cx="5098157" cy="1407914"/>
           </a:xfrm>
           <a:prstGeom prst="rect">
@@ -29590,458 +30311,6 @@
   <p:clrMapOvr>
     <a:masterClrMapping/>
   </p:clrMapOvr>
-</p:sld>
-</file>
-
-<file path=ppt/slides/slide6.xml><?xml version="1.0" encoding="utf-8"?>
-<p:sld xmlns:a="http://schemas.openxmlformats.org/drawingml/2006/main" xmlns:r="http://schemas.openxmlformats.org/officeDocument/2006/relationships" xmlns:p="http://schemas.openxmlformats.org/presentationml/2006/main">
-  <p:cSld>
-    <p:spTree>
-      <p:nvGrpSpPr>
-        <p:cNvPr id="1" name=""/>
-        <p:cNvGrpSpPr/>
-        <p:nvPr/>
-      </p:nvGrpSpPr>
-      <p:grpSpPr>
-        <a:xfrm>
-          <a:off x="0" y="0"/>
-          <a:ext cx="0" cy="0"/>
-          <a:chOff x="0" y="0"/>
-          <a:chExt cx="0" cy="0"/>
-        </a:xfrm>
-      </p:grpSpPr>
-      <p:sp>
-        <p:nvSpPr>
-          <p:cNvPr id="2" name="Title 1">
-            <a:extLst>
-              <a:ext uri="{FF2B5EF4-FFF2-40B4-BE49-F238E27FC236}">
-                <a16:creationId xmlns:a16="http://schemas.microsoft.com/office/drawing/2014/main" id="{8181DBF1-6B0C-F0AB-B6AE-072A389A2741}"/>
-              </a:ext>
-            </a:extLst>
-          </p:cNvPr>
-          <p:cNvSpPr>
-            <a:spLocks noGrp="1"/>
-          </p:cNvSpPr>
-          <p:nvPr>
-            <p:ph type="ctrTitle"/>
-          </p:nvPr>
-        </p:nvSpPr>
-        <p:spPr/>
-        <p:txBody>
-          <a:bodyPr/>
-          <a:lstStyle/>
-          <a:p>
-            <a:r>
-              <a:rPr lang="et-EE" noProof="0" dirty="0"/>
-              <a:t>Kuidas generatiivne tehisaru töötab?</a:t>
-            </a:r>
-          </a:p>
-        </p:txBody>
-      </p:sp>
-      <p:sp>
-        <p:nvSpPr>
-          <p:cNvPr id="9" name="TextBox 8">
-            <a:extLst>
-              <a:ext uri="{FF2B5EF4-FFF2-40B4-BE49-F238E27FC236}">
-                <a16:creationId xmlns:a16="http://schemas.microsoft.com/office/drawing/2014/main" id="{2C7597CA-D61E-17DA-17B5-C9C1738A73BE}"/>
-              </a:ext>
-            </a:extLst>
-          </p:cNvPr>
-          <p:cNvSpPr txBox="1"/>
-          <p:nvPr/>
-        </p:nvSpPr>
-        <p:spPr>
-          <a:xfrm>
-            <a:off x="650240" y="1188720"/>
-            <a:ext cx="5161280" cy="646331"/>
-          </a:xfrm>
-          <a:prstGeom prst="rect">
-            <a:avLst/>
-          </a:prstGeom>
-          <a:noFill/>
-        </p:spPr>
-        <p:txBody>
-          <a:bodyPr rot="0" spcFirstLastPara="0" vertOverflow="overflow" horzOverflow="overflow" vert="horz" wrap="square" lIns="91440" tIns="45720" rIns="91440" bIns="45720" numCol="1" spcCol="0" rtlCol="0" fromWordArt="0" anchor="t" anchorCtr="0" forceAA="0" compatLnSpc="1">
-            <a:prstTxWarp prst="textNoShape">
-              <a:avLst/>
-            </a:prstTxWarp>
-            <a:spAutoFit/>
-          </a:bodyPr>
-          <a:lstStyle/>
-          <a:p>
-            <a:pPr marL="285750" indent="-285750">
-              <a:buFont typeface="Arial"/>
-              <a:buChar char="•"/>
-            </a:pPr>
-            <a:r>
-              <a:rPr lang="et-EE" noProof="0" dirty="0">
-                <a:ea typeface="Inter"/>
-              </a:rPr>
-              <a:t>Mida arvasid ameeriklased augustis 2025:</a:t>
-            </a:r>
-            <a:endParaRPr lang="et-EE" noProof="0" dirty="0"/>
-          </a:p>
-          <a:p>
-            <a:pPr marL="285750" indent="-285750">
-              <a:buFont typeface="Arial"/>
-              <a:buChar char="•"/>
-            </a:pPr>
-            <a:endParaRPr lang="et-EE" noProof="0" dirty="0"/>
-          </a:p>
-        </p:txBody>
-      </p:sp>
-      <p:pic>
-        <p:nvPicPr>
-          <p:cNvPr id="12" name="Content Placeholder 11">
-            <a:extLst>
-              <a:ext uri="{FF2B5EF4-FFF2-40B4-BE49-F238E27FC236}">
-                <a16:creationId xmlns:a16="http://schemas.microsoft.com/office/drawing/2014/main" id="{DDF6099E-FFF5-3B8B-6ED0-48C668AABFB9}"/>
-              </a:ext>
-            </a:extLst>
-          </p:cNvPr>
-          <p:cNvPicPr>
-            <a:picLocks noGrp="1" noChangeAspect="1"/>
-          </p:cNvPicPr>
-          <p:nvPr>
-            <p:ph sz="quarter" idx="10"/>
-          </p:nvPr>
-        </p:nvPicPr>
-        <p:blipFill>
-          <a:blip r:embed="rId2"/>
-          <a:stretch>
-            <a:fillRect/>
-          </a:stretch>
-        </p:blipFill>
-        <p:spPr>
-          <a:xfrm>
-            <a:off x="2055813" y="1836261"/>
-            <a:ext cx="8077200" cy="4000500"/>
-          </a:xfrm>
-          <a:prstGeom prst="rect">
-            <a:avLst/>
-          </a:prstGeom>
-          <a:solidFill>
-            <a:srgbClr val="FFFFFF">
-              <a:shade val="85000"/>
-            </a:srgbClr>
-          </a:solidFill>
-          <a:ln w="88900" cap="sq">
-            <a:solidFill>
-              <a:srgbClr val="FFFFFF"/>
-            </a:solidFill>
-            <a:miter lim="800000"/>
-          </a:ln>
-          <a:effectLst>
-            <a:outerShdw blurRad="55000" dist="18000" dir="5400000" algn="tl" rotWithShape="0">
-              <a:srgbClr val="000000">
-                <a:alpha val="40000"/>
-              </a:srgbClr>
-            </a:outerShdw>
-          </a:effectLst>
-          <a:scene3d>
-            <a:camera prst="orthographicFront"/>
-            <a:lightRig rig="twoPt" dir="t">
-              <a:rot lat="0" lon="0" rev="7200000"/>
-            </a:lightRig>
-          </a:scene3d>
-          <a:sp3d>
-            <a:bevelT w="25400" h="19050"/>
-            <a:contourClr>
-              <a:srgbClr val="FFFFFF"/>
-            </a:contourClr>
-          </a:sp3d>
-        </p:spPr>
-      </p:pic>
-      <p:sp>
-        <p:nvSpPr>
-          <p:cNvPr id="13" name="TextBox 12">
-            <a:extLst>
-              <a:ext uri="{FF2B5EF4-FFF2-40B4-BE49-F238E27FC236}">
-                <a16:creationId xmlns:a16="http://schemas.microsoft.com/office/drawing/2014/main" id="{7D4B374B-E0FB-F26A-AAD2-2AA0ED2D1C5C}"/>
-              </a:ext>
-            </a:extLst>
-          </p:cNvPr>
-          <p:cNvSpPr txBox="1"/>
-          <p:nvPr/>
-        </p:nvSpPr>
-        <p:spPr>
-          <a:xfrm>
-            <a:off x="2692400" y="6014720"/>
-            <a:ext cx="7518400" cy="923330"/>
-          </a:xfrm>
-          <a:prstGeom prst="rect">
-            <a:avLst/>
-          </a:prstGeom>
-          <a:noFill/>
-        </p:spPr>
-        <p:txBody>
-          <a:bodyPr rot="0" spcFirstLastPara="0" vertOverflow="overflow" horzOverflow="overflow" vert="horz" wrap="square" lIns="91440" tIns="45720" rIns="91440" bIns="45720" numCol="1" spcCol="0" rtlCol="0" fromWordArt="0" anchor="t" anchorCtr="0" forceAA="0" compatLnSpc="1">
-            <a:prstTxWarp prst="textNoShape">
-              <a:avLst/>
-            </a:prstTxWarp>
-            <a:spAutoFit/>
-          </a:bodyPr>
-          <a:lstStyle/>
-          <a:p>
-            <a:pPr algn="r"/>
-            <a:r>
-              <a:rPr lang="et-EE" sz="1400" noProof="0" dirty="0">
-                <a:ea typeface="Inter"/>
-              </a:rPr>
-              <a:t>Allikas:</a:t>
-            </a:r>
-            <a:r>
-              <a:rPr lang="et-EE" sz="1400" noProof="0" dirty="0">
-                <a:ea typeface="+mn-lt"/>
-                <a:cs typeface="+mn-lt"/>
-              </a:rPr>
-              <a:t> </a:t>
-            </a:r>
-            <a:r>
-              <a:rPr lang="et-EE" sz="1400" noProof="0" dirty="0" err="1">
-                <a:ea typeface="+mn-lt"/>
-                <a:cs typeface="+mn-lt"/>
-                <a:hlinkClick r:id="rId3"/>
-              </a:rPr>
-              <a:t>Searchlight</a:t>
-            </a:r>
-            <a:r>
-              <a:rPr lang="et-EE" sz="1400" noProof="0" dirty="0">
-                <a:ea typeface="+mn-lt"/>
-                <a:cs typeface="+mn-lt"/>
-                <a:hlinkClick r:id="rId3"/>
-              </a:rPr>
-              <a:t> </a:t>
-            </a:r>
-            <a:r>
-              <a:rPr lang="et-EE" sz="1400" noProof="0" dirty="0" err="1">
-                <a:ea typeface="+mn-lt"/>
-                <a:cs typeface="+mn-lt"/>
-                <a:hlinkClick r:id="rId3"/>
-              </a:rPr>
-              <a:t>Institute</a:t>
-            </a:r>
-            <a:r>
-              <a:rPr lang="et-EE" sz="1400" noProof="0" dirty="0">
-                <a:ea typeface="+mn-lt"/>
-                <a:cs typeface="+mn-lt"/>
-                <a:hlinkClick r:id="rId3"/>
-              </a:rPr>
-              <a:t> ja Tavern Research uuring AI kohta</a:t>
-            </a:r>
-            <a:r>
-              <a:rPr lang="et-EE" sz="1400" noProof="0" dirty="0">
-                <a:ea typeface="+mn-lt"/>
-                <a:cs typeface="+mn-lt"/>
-              </a:rPr>
-              <a:t>.</a:t>
-            </a:r>
-            <a:r>
-              <a:rPr lang="et-EE" noProof="0" dirty="0">
-                <a:ea typeface="+mn-lt"/>
-                <a:cs typeface="+mn-lt"/>
-              </a:rPr>
-              <a:t> </a:t>
-            </a:r>
-            <a:endParaRPr lang="et-EE" noProof="0" dirty="0">
-              <a:ea typeface="Inter"/>
-            </a:endParaRPr>
-          </a:p>
-          <a:p>
-            <a:pPr algn="r"/>
-            <a:endParaRPr lang="et-EE" noProof="0" dirty="0">
-              <a:solidFill>
-                <a:srgbClr val="121212"/>
-              </a:solidFill>
-              <a:ea typeface="Inter"/>
-            </a:endParaRPr>
-          </a:p>
-          <a:p>
-            <a:endParaRPr lang="et-EE" noProof="0" dirty="0">
-              <a:ea typeface="Inter"/>
-            </a:endParaRPr>
-          </a:p>
-        </p:txBody>
-      </p:sp>
-    </p:spTree>
-    <p:extLst>
-      <p:ext uri="{BB962C8B-B14F-4D97-AF65-F5344CB8AC3E}">
-        <p14:creationId xmlns:p14="http://schemas.microsoft.com/office/powerpoint/2010/main" val="3557357758"/>
-      </p:ext>
-    </p:extLst>
-  </p:cSld>
-  <p:clrMapOvr>
-    <a:masterClrMapping/>
-  </p:clrMapOvr>
-  <p:timing>
-    <p:tnLst>
-      <p:par>
-        <p:cTn id="1" dur="indefinite" restart="never" nodeType="tmRoot">
-          <p:childTnLst>
-            <p:seq concurrent="1" nextAc="seek">
-              <p:cTn id="2" dur="indefinite" nodeType="mainSeq">
-                <p:childTnLst>
-                  <p:par>
-                    <p:cTn id="3" fill="hold">
-                      <p:stCondLst>
-                        <p:cond delay="indefinite"/>
-                      </p:stCondLst>
-                      <p:childTnLst>
-                        <p:par>
-                          <p:cTn id="4" fill="hold">
-                            <p:stCondLst>
-                              <p:cond delay="0"/>
-                            </p:stCondLst>
-                            <p:childTnLst>
-                              <p:par>
-                                <p:cTn id="5" presetID="1" presetClass="entr" presetSubtype="0" fill="hold" grpId="0" nodeType="clickEffect">
-                                  <p:stCondLst>
-                                    <p:cond delay="0"/>
-                                  </p:stCondLst>
-                                  <p:childTnLst>
-                                    <p:set>
-                                      <p:cBhvr>
-                                        <p:cTn id="6" dur="1" fill="hold">
-                                          <p:stCondLst>
-                                            <p:cond delay="0"/>
-                                          </p:stCondLst>
-                                        </p:cTn>
-                                        <p:tgtEl>
-                                          <p:spTgt spid="9"/>
-                                        </p:tgtEl>
-                                        <p:attrNameLst>
-                                          <p:attrName>style.visibility</p:attrName>
-                                        </p:attrNameLst>
-                                      </p:cBhvr>
-                                      <p:to>
-                                        <p:strVal val="visible"/>
-                                      </p:to>
-                                    </p:set>
-                                  </p:childTnLst>
-                                </p:cTn>
-                              </p:par>
-                            </p:childTnLst>
-                          </p:cTn>
-                        </p:par>
-                      </p:childTnLst>
-                    </p:cTn>
-                  </p:par>
-                  <p:par>
-                    <p:cTn id="7" fill="hold">
-                      <p:stCondLst>
-                        <p:cond delay="indefinite"/>
-                      </p:stCondLst>
-                      <p:childTnLst>
-                        <p:par>
-                          <p:cTn id="8" fill="hold">
-                            <p:stCondLst>
-                              <p:cond delay="0"/>
-                            </p:stCondLst>
-                            <p:childTnLst>
-                              <p:par>
-                                <p:cTn id="9" presetID="1" presetClass="entr" presetSubtype="0" fill="hold" nodeType="clickEffect">
-                                  <p:stCondLst>
-                                    <p:cond delay="0"/>
-                                  </p:stCondLst>
-                                  <p:childTnLst>
-                                    <p:set>
-                                      <p:cBhvr>
-                                        <p:cTn id="10" dur="1" fill="hold">
-                                          <p:stCondLst>
-                                            <p:cond delay="0"/>
-                                          </p:stCondLst>
-                                        </p:cTn>
-                                        <p:tgtEl>
-                                          <p:spTgt spid="12"/>
-                                        </p:tgtEl>
-                                        <p:attrNameLst>
-                                          <p:attrName>style.visibility</p:attrName>
-                                        </p:attrNameLst>
-                                      </p:cBhvr>
-                                      <p:to>
-                                        <p:strVal val="visible"/>
-                                      </p:to>
-                                    </p:set>
-                                  </p:childTnLst>
-                                </p:cTn>
-                              </p:par>
-                            </p:childTnLst>
-                          </p:cTn>
-                        </p:par>
-                      </p:childTnLst>
-                    </p:cTn>
-                  </p:par>
-                  <p:par>
-                    <p:cTn id="11" fill="hold">
-                      <p:stCondLst>
-                        <p:cond delay="indefinite"/>
-                      </p:stCondLst>
-                      <p:childTnLst>
-                        <p:par>
-                          <p:cTn id="12" fill="hold">
-                            <p:stCondLst>
-                              <p:cond delay="0"/>
-                            </p:stCondLst>
-                            <p:childTnLst>
-                              <p:par>
-                                <p:cTn id="13" presetID="1" presetClass="entr" presetSubtype="0" fill="hold" grpId="0" nodeType="clickEffect">
-                                  <p:stCondLst>
-                                    <p:cond delay="0"/>
-                                  </p:stCondLst>
-                                  <p:childTnLst>
-                                    <p:set>
-                                      <p:cBhvr>
-                                        <p:cTn id="14" dur="1" fill="hold">
-                                          <p:stCondLst>
-                                            <p:cond delay="0"/>
-                                          </p:stCondLst>
-                                        </p:cTn>
-                                        <p:tgtEl>
-                                          <p:spTgt spid="13"/>
-                                        </p:tgtEl>
-                                        <p:attrNameLst>
-                                          <p:attrName>style.visibility</p:attrName>
-                                        </p:attrNameLst>
-                                      </p:cBhvr>
-                                      <p:to>
-                                        <p:strVal val="visible"/>
-                                      </p:to>
-                                    </p:set>
-                                  </p:childTnLst>
-                                </p:cTn>
-                              </p:par>
-                            </p:childTnLst>
-                          </p:cTn>
-                        </p:par>
-                      </p:childTnLst>
-                    </p:cTn>
-                  </p:par>
-                </p:childTnLst>
-              </p:cTn>
-              <p:prevCondLst>
-                <p:cond evt="onPrev" delay="0">
-                  <p:tgtEl>
-                    <p:sldTgt/>
-                  </p:tgtEl>
-                </p:cond>
-              </p:prevCondLst>
-              <p:nextCondLst>
-                <p:cond evt="onNext" delay="0">
-                  <p:tgtEl>
-                    <p:sldTgt/>
-                  </p:tgtEl>
-                </p:cond>
-              </p:nextCondLst>
-            </p:seq>
-          </p:childTnLst>
-        </p:cTn>
-      </p:par>
-    </p:tnLst>
-    <p:bldLst>
-      <p:bldP spid="9" grpId="0"/>
-      <p:bldP spid="13" grpId="0"/>
-    </p:bldLst>
-  </p:timing>
 </p:sld>
 </file>
 
@@ -30215,9 +30484,86 @@
               </a:rPr>
               <a:t>https://digiriigiakadeemia.ee/course/index.php?categoryid=60</a:t>
             </a:r>
+            <a:endParaRPr lang="en-US" sz="2400" dirty="0"/>
+          </a:p>
+          <a:p>
+            <a:pPr lvl="1">
+              <a:lnSpc>
+                <a:spcPct val="150000"/>
+              </a:lnSpc>
+            </a:pPr>
+            <a:endParaRPr lang="en-US" sz="2400" dirty="0"/>
+          </a:p>
+          <a:p>
+            <a:pPr>
+              <a:lnSpc>
+                <a:spcPct val="150000"/>
+              </a:lnSpc>
+            </a:pPr>
+            <a:r>
+              <a:rPr lang="en-US" sz="2400" dirty="0" err="1"/>
+              <a:t>Lühike</a:t>
+            </a:r>
             <a:r>
               <a:rPr lang="en-US" sz="2400" dirty="0"/>
               <a:t> </a:t>
+            </a:r>
+            <a:r>
+              <a:rPr lang="en-US" sz="2400" dirty="0" err="1"/>
+              <a:t>ingliskeelne</a:t>
+            </a:r>
+            <a:r>
+              <a:rPr lang="en-US" sz="2400" dirty="0"/>
+              <a:t> </a:t>
+            </a:r>
+            <a:r>
+              <a:rPr lang="en-US" sz="2400" dirty="0" err="1"/>
+              <a:t>tutvustus</a:t>
+            </a:r>
+            <a:r>
+              <a:rPr lang="en-US" sz="2400" dirty="0"/>
+              <a:t> </a:t>
+            </a:r>
+            <a:r>
+              <a:rPr lang="en-US" sz="2400" dirty="0" err="1"/>
+              <a:t>keelemudelite</a:t>
+            </a:r>
+            <a:r>
+              <a:rPr lang="en-US" sz="2400" dirty="0"/>
+              <a:t> </a:t>
+            </a:r>
+            <a:r>
+              <a:rPr lang="en-US" sz="2400" dirty="0" err="1"/>
+              <a:t>toimimise</a:t>
+            </a:r>
+            <a:r>
+              <a:rPr lang="en-US" sz="2400" dirty="0"/>
+              <a:t> </a:t>
+            </a:r>
+            <a:r>
+              <a:rPr lang="en-US" sz="2400" dirty="0" err="1"/>
+              <a:t>kohta</a:t>
+            </a:r>
+            <a:r>
+              <a:rPr lang="en-US" sz="2400" dirty="0"/>
+              <a:t>: </a:t>
+            </a:r>
+          </a:p>
+          <a:p>
+            <a:pPr lvl="1">
+              <a:lnSpc>
+                <a:spcPct val="150000"/>
+              </a:lnSpc>
+            </a:pPr>
+            <a:r>
+              <a:rPr lang="en-US" sz="2400" dirty="0">
+                <a:hlinkClick r:id="rId4"/>
+              </a:rPr>
+              <a:t>https://youtu.be/LPZh9BOjkQs?si=Z3O5J0zhSEZG9TWc</a:t>
+            </a:r>
+            <a:r>
+              <a:rPr lang="en-US" sz="2400" dirty="0"/>
+              <a:t>  </a:t>
             </a:r>
             <a:endParaRPr lang="et-EE" sz="2400" dirty="0"/>
           </a:p>

</xml_diff>